<commit_message>
docs: finalize PowerPoint presentation metadata
</commit_message>
<xml_diff>
--- a/docs/LUMEA_Beauty_Product_Presentation.pptx
+++ b/docs/LUMEA_Beauty_Product_Presentation.pptx
@@ -5,18 +5,18 @@
     <p:sldMasterId id="2147483648" r:id="rId1"/>
   </p:sldMasterIdLst>
   <p:sldIdLst>
-    <p:sldId id="256" r:id="rId7"/>
-    <p:sldId id="257" r:id="rId8"/>
-    <p:sldId id="258" r:id="rId9"/>
-    <p:sldId id="259" r:id="rId10"/>
-    <p:sldId id="260" r:id="rId11"/>
-    <p:sldId id="261" r:id="rId12"/>
-    <p:sldId id="262" r:id="rId13"/>
-    <p:sldId id="263" r:id="rId14"/>
-    <p:sldId id="264" r:id="rId15"/>
-    <p:sldId id="265" r:id="rId16"/>
+    <p:sldId id="256" r:id="rId2"/>
+    <p:sldId id="257" r:id="rId3"/>
+    <p:sldId id="258" r:id="rId4"/>
+    <p:sldId id="259" r:id="rId5"/>
+    <p:sldId id="260" r:id="rId6"/>
+    <p:sldId id="261" r:id="rId7"/>
+    <p:sldId id="262" r:id="rId8"/>
+    <p:sldId id="263" r:id="rId9"/>
+    <p:sldId id="264" r:id="rId10"/>
+    <p:sldId id="265" r:id="rId11"/>
   </p:sldIdLst>
-  <p:sldSz cx="12191695" cy="6858000" type="screen4x3"/>
+  <p:sldSz cx="12192000" cy="6858000"/>
   <p:notesSz cx="6858000" cy="9144000"/>
   <p:defaultTextStyle>
     <a:defPPr>
@@ -113,6 +113,22 @@
       </a:defRPr>
     </a:lvl9pPr>
   </p:defaultTextStyle>
+  <p:extLst>
+    <p:ext uri="{EFAFB233-063F-42B5-8137-9DF3F51BA10A}">
+      <p15:sldGuideLst xmlns:p15="http://schemas.microsoft.com/office/powerpoint/2012/main">
+        <p15:guide id="1" orient="horz" pos="2160">
+          <p15:clr>
+            <a:srgbClr val="A4A3A4"/>
+          </p15:clr>
+        </p15:guide>
+        <p15:guide id="2" pos="2880">
+          <p15:clr>
+            <a:srgbClr val="A4A3A4"/>
+          </p15:clr>
+        </p15:guide>
+      </p15:sldGuideLst>
+    </p:ext>
+  </p:extLst>
 </p:presentation>
 </file>
 
@@ -154,10 +170,9 @@
           <a:lstStyle/>
           <a:p>
             <a:r>
-              <a:rPr lang="en-US" smtClean="0"/>
+              <a:rPr lang="en-US"/>
               <a:t>Click to edit Master title style</a:t>
             </a:r>
-            <a:endParaRPr lang="en-US"/>
           </a:p>
         </p:txBody>
       </p:sp>
@@ -273,10 +288,9 @@
           </a:lstStyle>
           <a:p>
             <a:r>
-              <a:rPr lang="en-US" smtClean="0"/>
+              <a:rPr lang="en-US"/>
               <a:t>Click to edit Master subtitle style</a:t>
             </a:r>
-            <a:endParaRPr lang="en-US"/>
           </a:p>
         </p:txBody>
       </p:sp>
@@ -297,7 +311,7 @@
           <a:p>
             <a:fld id="{5BCAD085-E8A6-8845-BD4E-CB4CCA059FC4}" type="datetimeFigureOut">
               <a:rPr lang="en-US" smtClean="0"/>
-              <a:t>1/27/13</a:t>
+              <a:t>9/21/2026</a:t>
             </a:fld>
             <a:endParaRPr lang="en-US"/>
           </a:p>
@@ -391,10 +405,9 @@
           <a:lstStyle/>
           <a:p>
             <a:r>
-              <a:rPr lang="en-US" smtClean="0"/>
+              <a:rPr lang="en-US"/>
               <a:t>Click to edit Master title style</a:t>
             </a:r>
-            <a:endParaRPr lang="en-US"/>
           </a:p>
         </p:txBody>
       </p:sp>
@@ -415,38 +428,37 @@
           <a:p>
             <a:pPr lvl="0"/>
             <a:r>
-              <a:rPr lang="en-US" smtClean="0"/>
+              <a:rPr lang="en-US"/>
               <a:t>Click to edit Master text styles</a:t>
             </a:r>
           </a:p>
           <a:p>
             <a:pPr lvl="1"/>
             <a:r>
-              <a:rPr lang="en-US" smtClean="0"/>
+              <a:rPr lang="en-US"/>
               <a:t>Second level</a:t>
             </a:r>
           </a:p>
           <a:p>
             <a:pPr lvl="2"/>
             <a:r>
-              <a:rPr lang="en-US" smtClean="0"/>
+              <a:rPr lang="en-US"/>
               <a:t>Third level</a:t>
             </a:r>
           </a:p>
           <a:p>
             <a:pPr lvl="3"/>
             <a:r>
-              <a:rPr lang="en-US" smtClean="0"/>
+              <a:rPr lang="en-US"/>
               <a:t>Fourth level</a:t>
             </a:r>
           </a:p>
           <a:p>
             <a:pPr lvl="4"/>
             <a:r>
-              <a:rPr lang="en-US" smtClean="0"/>
+              <a:rPr lang="en-US"/>
               <a:t>Fifth level</a:t>
             </a:r>
-            <a:endParaRPr lang="en-US"/>
           </a:p>
         </p:txBody>
       </p:sp>
@@ -467,7 +479,7 @@
           <a:p>
             <a:fld id="{5BCAD085-E8A6-8845-BD4E-CB4CCA059FC4}" type="datetimeFigureOut">
               <a:rPr lang="en-US" smtClean="0"/>
-              <a:t>1/27/13</a:t>
+              <a:t>9/21/2026</a:t>
             </a:fld>
             <a:endParaRPr lang="en-US"/>
           </a:p>
@@ -566,10 +578,9 @@
           <a:lstStyle/>
           <a:p>
             <a:r>
-              <a:rPr lang="en-US" smtClean="0"/>
+              <a:rPr lang="en-US"/>
               <a:t>Click to edit Master title style</a:t>
             </a:r>
-            <a:endParaRPr lang="en-US"/>
           </a:p>
         </p:txBody>
       </p:sp>
@@ -595,38 +606,37 @@
           <a:p>
             <a:pPr lvl="0"/>
             <a:r>
-              <a:rPr lang="en-US" smtClean="0"/>
+              <a:rPr lang="en-US"/>
               <a:t>Click to edit Master text styles</a:t>
             </a:r>
           </a:p>
           <a:p>
             <a:pPr lvl="1"/>
             <a:r>
-              <a:rPr lang="en-US" smtClean="0"/>
+              <a:rPr lang="en-US"/>
               <a:t>Second level</a:t>
             </a:r>
           </a:p>
           <a:p>
             <a:pPr lvl="2"/>
             <a:r>
-              <a:rPr lang="en-US" smtClean="0"/>
+              <a:rPr lang="en-US"/>
               <a:t>Third level</a:t>
             </a:r>
           </a:p>
           <a:p>
             <a:pPr lvl="3"/>
             <a:r>
-              <a:rPr lang="en-US" smtClean="0"/>
+              <a:rPr lang="en-US"/>
               <a:t>Fourth level</a:t>
             </a:r>
           </a:p>
           <a:p>
             <a:pPr lvl="4"/>
             <a:r>
-              <a:rPr lang="en-US" smtClean="0"/>
+              <a:rPr lang="en-US"/>
               <a:t>Fifth level</a:t>
             </a:r>
-            <a:endParaRPr lang="en-US"/>
           </a:p>
         </p:txBody>
       </p:sp>
@@ -647,7 +657,7 @@
           <a:p>
             <a:fld id="{5BCAD085-E8A6-8845-BD4E-CB4CCA059FC4}" type="datetimeFigureOut">
               <a:rPr lang="en-US" smtClean="0"/>
-              <a:t>1/27/13</a:t>
+              <a:t>9/21/2026</a:t>
             </a:fld>
             <a:endParaRPr lang="en-US"/>
           </a:p>
@@ -741,10 +751,9 @@
           <a:lstStyle/>
           <a:p>
             <a:r>
-              <a:rPr lang="en-US" smtClean="0"/>
+              <a:rPr lang="en-US"/>
               <a:t>Click to edit Master title style</a:t>
             </a:r>
-            <a:endParaRPr lang="en-US"/>
           </a:p>
         </p:txBody>
       </p:sp>
@@ -765,38 +774,37 @@
           <a:p>
             <a:pPr lvl="0"/>
             <a:r>
-              <a:rPr lang="en-US" smtClean="0"/>
+              <a:rPr lang="en-US"/>
               <a:t>Click to edit Master text styles</a:t>
             </a:r>
           </a:p>
           <a:p>
             <a:pPr lvl="1"/>
             <a:r>
-              <a:rPr lang="en-US" smtClean="0"/>
+              <a:rPr lang="en-US"/>
               <a:t>Second level</a:t>
             </a:r>
           </a:p>
           <a:p>
             <a:pPr lvl="2"/>
             <a:r>
-              <a:rPr lang="en-US" smtClean="0"/>
+              <a:rPr lang="en-US"/>
               <a:t>Third level</a:t>
             </a:r>
           </a:p>
           <a:p>
             <a:pPr lvl="3"/>
             <a:r>
-              <a:rPr lang="en-US" smtClean="0"/>
+              <a:rPr lang="en-US"/>
               <a:t>Fourth level</a:t>
             </a:r>
           </a:p>
           <a:p>
             <a:pPr lvl="4"/>
             <a:r>
-              <a:rPr lang="en-US" smtClean="0"/>
+              <a:rPr lang="en-US"/>
               <a:t>Fifth level</a:t>
             </a:r>
-            <a:endParaRPr lang="en-US"/>
           </a:p>
         </p:txBody>
       </p:sp>
@@ -817,7 +825,7 @@
           <a:p>
             <a:fld id="{5BCAD085-E8A6-8845-BD4E-CB4CCA059FC4}" type="datetimeFigureOut">
               <a:rPr lang="en-US" smtClean="0"/>
-              <a:t>1/27/13</a:t>
+              <a:t>9/21/2026</a:t>
             </a:fld>
             <a:endParaRPr lang="en-US"/>
           </a:p>
@@ -920,10 +928,9 @@
           </a:lstStyle>
           <a:p>
             <a:r>
-              <a:rPr lang="en-US" smtClean="0"/>
+              <a:rPr lang="en-US"/>
               <a:t>Click to edit Master title style</a:t>
             </a:r>
-            <a:endParaRPr lang="en-US"/>
           </a:p>
         </p:txBody>
       </p:sp>
@@ -1040,7 +1047,7 @@
           <a:p>
             <a:pPr lvl="0"/>
             <a:r>
-              <a:rPr lang="en-US" smtClean="0"/>
+              <a:rPr lang="en-US"/>
               <a:t>Click to edit Master text styles</a:t>
             </a:r>
           </a:p>
@@ -1063,7 +1070,7 @@
           <a:p>
             <a:fld id="{5BCAD085-E8A6-8845-BD4E-CB4CCA059FC4}" type="datetimeFigureOut">
               <a:rPr lang="en-US" smtClean="0"/>
-              <a:t>1/27/13</a:t>
+              <a:t>9/21/2026</a:t>
             </a:fld>
             <a:endParaRPr lang="en-US"/>
           </a:p>
@@ -1157,10 +1164,9 @@
           <a:lstStyle/>
           <a:p>
             <a:r>
-              <a:rPr lang="en-US" smtClean="0"/>
+              <a:rPr lang="en-US"/>
               <a:t>Click to edit Master title style</a:t>
             </a:r>
-            <a:endParaRPr lang="en-US"/>
           </a:p>
         </p:txBody>
       </p:sp>
@@ -1214,38 +1220,37 @@
           <a:p>
             <a:pPr lvl="0"/>
             <a:r>
-              <a:rPr lang="en-US" smtClean="0"/>
+              <a:rPr lang="en-US"/>
               <a:t>Click to edit Master text styles</a:t>
             </a:r>
           </a:p>
           <a:p>
             <a:pPr lvl="1"/>
             <a:r>
-              <a:rPr lang="en-US" smtClean="0"/>
+              <a:rPr lang="en-US"/>
               <a:t>Second level</a:t>
             </a:r>
           </a:p>
           <a:p>
             <a:pPr lvl="2"/>
             <a:r>
-              <a:rPr lang="en-US" smtClean="0"/>
+              <a:rPr lang="en-US"/>
               <a:t>Third level</a:t>
             </a:r>
           </a:p>
           <a:p>
             <a:pPr lvl="3"/>
             <a:r>
-              <a:rPr lang="en-US" smtClean="0"/>
+              <a:rPr lang="en-US"/>
               <a:t>Fourth level</a:t>
             </a:r>
           </a:p>
           <a:p>
             <a:pPr lvl="4"/>
             <a:r>
-              <a:rPr lang="en-US" smtClean="0"/>
+              <a:rPr lang="en-US"/>
               <a:t>Fifth level</a:t>
             </a:r>
-            <a:endParaRPr lang="en-US"/>
           </a:p>
         </p:txBody>
       </p:sp>
@@ -1299,38 +1304,37 @@
           <a:p>
             <a:pPr lvl="0"/>
             <a:r>
-              <a:rPr lang="en-US" smtClean="0"/>
+              <a:rPr lang="en-US"/>
               <a:t>Click to edit Master text styles</a:t>
             </a:r>
           </a:p>
           <a:p>
             <a:pPr lvl="1"/>
             <a:r>
-              <a:rPr lang="en-US" smtClean="0"/>
+              <a:rPr lang="en-US"/>
               <a:t>Second level</a:t>
             </a:r>
           </a:p>
           <a:p>
             <a:pPr lvl="2"/>
             <a:r>
-              <a:rPr lang="en-US" smtClean="0"/>
+              <a:rPr lang="en-US"/>
               <a:t>Third level</a:t>
             </a:r>
           </a:p>
           <a:p>
             <a:pPr lvl="3"/>
             <a:r>
-              <a:rPr lang="en-US" smtClean="0"/>
+              <a:rPr lang="en-US"/>
               <a:t>Fourth level</a:t>
             </a:r>
           </a:p>
           <a:p>
             <a:pPr lvl="4"/>
             <a:r>
-              <a:rPr lang="en-US" smtClean="0"/>
+              <a:rPr lang="en-US"/>
               <a:t>Fifth level</a:t>
             </a:r>
-            <a:endParaRPr lang="en-US"/>
           </a:p>
         </p:txBody>
       </p:sp>
@@ -1351,7 +1355,7 @@
           <a:p>
             <a:fld id="{5BCAD085-E8A6-8845-BD4E-CB4CCA059FC4}" type="datetimeFigureOut">
               <a:rPr lang="en-US" smtClean="0"/>
-              <a:t>1/27/13</a:t>
+              <a:t>9/21/2026</a:t>
             </a:fld>
             <a:endParaRPr lang="en-US"/>
           </a:p>
@@ -1449,10 +1453,9 @@
           </a:lstStyle>
           <a:p>
             <a:r>
-              <a:rPr lang="en-US" smtClean="0"/>
+              <a:rPr lang="en-US"/>
               <a:t>Click to edit Master title style</a:t>
             </a:r>
-            <a:endParaRPr lang="en-US"/>
           </a:p>
         </p:txBody>
       </p:sp>
@@ -1515,7 +1518,7 @@
           <a:p>
             <a:pPr lvl="0"/>
             <a:r>
-              <a:rPr lang="en-US" smtClean="0"/>
+              <a:rPr lang="en-US"/>
               <a:t>Click to edit Master text styles</a:t>
             </a:r>
           </a:p>
@@ -1571,38 +1574,37 @@
           <a:p>
             <a:pPr lvl="0"/>
             <a:r>
-              <a:rPr lang="en-US" smtClean="0"/>
+              <a:rPr lang="en-US"/>
               <a:t>Click to edit Master text styles</a:t>
             </a:r>
           </a:p>
           <a:p>
             <a:pPr lvl="1"/>
             <a:r>
-              <a:rPr lang="en-US" smtClean="0"/>
+              <a:rPr lang="en-US"/>
               <a:t>Second level</a:t>
             </a:r>
           </a:p>
           <a:p>
             <a:pPr lvl="2"/>
             <a:r>
-              <a:rPr lang="en-US" smtClean="0"/>
+              <a:rPr lang="en-US"/>
               <a:t>Third level</a:t>
             </a:r>
           </a:p>
           <a:p>
             <a:pPr lvl="3"/>
             <a:r>
-              <a:rPr lang="en-US" smtClean="0"/>
+              <a:rPr lang="en-US"/>
               <a:t>Fourth level</a:t>
             </a:r>
           </a:p>
           <a:p>
             <a:pPr lvl="4"/>
             <a:r>
-              <a:rPr lang="en-US" smtClean="0"/>
+              <a:rPr lang="en-US"/>
               <a:t>Fifth level</a:t>
             </a:r>
-            <a:endParaRPr lang="en-US"/>
           </a:p>
         </p:txBody>
       </p:sp>
@@ -1665,7 +1667,7 @@
           <a:p>
             <a:pPr lvl="0"/>
             <a:r>
-              <a:rPr lang="en-US" smtClean="0"/>
+              <a:rPr lang="en-US"/>
               <a:t>Click to edit Master text styles</a:t>
             </a:r>
           </a:p>
@@ -1721,38 +1723,37 @@
           <a:p>
             <a:pPr lvl="0"/>
             <a:r>
-              <a:rPr lang="en-US" smtClean="0"/>
+              <a:rPr lang="en-US"/>
               <a:t>Click to edit Master text styles</a:t>
             </a:r>
           </a:p>
           <a:p>
             <a:pPr lvl="1"/>
             <a:r>
-              <a:rPr lang="en-US" smtClean="0"/>
+              <a:rPr lang="en-US"/>
               <a:t>Second level</a:t>
             </a:r>
           </a:p>
           <a:p>
             <a:pPr lvl="2"/>
             <a:r>
-              <a:rPr lang="en-US" smtClean="0"/>
+              <a:rPr lang="en-US"/>
               <a:t>Third level</a:t>
             </a:r>
           </a:p>
           <a:p>
             <a:pPr lvl="3"/>
             <a:r>
-              <a:rPr lang="en-US" smtClean="0"/>
+              <a:rPr lang="en-US"/>
               <a:t>Fourth level</a:t>
             </a:r>
           </a:p>
           <a:p>
             <a:pPr lvl="4"/>
             <a:r>
-              <a:rPr lang="en-US" smtClean="0"/>
+              <a:rPr lang="en-US"/>
               <a:t>Fifth level</a:t>
             </a:r>
-            <a:endParaRPr lang="en-US"/>
           </a:p>
         </p:txBody>
       </p:sp>
@@ -1773,7 +1774,7 @@
           <a:p>
             <a:fld id="{5BCAD085-E8A6-8845-BD4E-CB4CCA059FC4}" type="datetimeFigureOut">
               <a:rPr lang="en-US" smtClean="0"/>
-              <a:t>1/27/13</a:t>
+              <a:t>9/21/2026</a:t>
             </a:fld>
             <a:endParaRPr lang="en-US"/>
           </a:p>
@@ -1867,10 +1868,9 @@
           <a:lstStyle/>
           <a:p>
             <a:r>
-              <a:rPr lang="en-US" smtClean="0"/>
+              <a:rPr lang="en-US"/>
               <a:t>Click to edit Master title style</a:t>
             </a:r>
-            <a:endParaRPr lang="en-US"/>
           </a:p>
         </p:txBody>
       </p:sp>
@@ -1891,7 +1891,7 @@
           <a:p>
             <a:fld id="{5BCAD085-E8A6-8845-BD4E-CB4CCA059FC4}" type="datetimeFigureOut">
               <a:rPr lang="en-US" smtClean="0"/>
-              <a:t>1/27/13</a:t>
+              <a:t>9/21/2026</a:t>
             </a:fld>
             <a:endParaRPr lang="en-US"/>
           </a:p>
@@ -1986,7 +1986,7 @@
           <a:p>
             <a:fld id="{5BCAD085-E8A6-8845-BD4E-CB4CCA059FC4}" type="datetimeFigureOut">
               <a:rPr lang="en-US" smtClean="0"/>
-              <a:t>1/27/13</a:t>
+              <a:t>9/21/2026</a:t>
             </a:fld>
             <a:endParaRPr lang="en-US"/>
           </a:p>
@@ -2089,10 +2089,9 @@
           </a:lstStyle>
           <a:p>
             <a:r>
-              <a:rPr lang="en-US" smtClean="0"/>
+              <a:rPr lang="en-US"/>
               <a:t>Click to edit Master title style</a:t>
             </a:r>
-            <a:endParaRPr lang="en-US"/>
           </a:p>
         </p:txBody>
       </p:sp>
@@ -2146,38 +2145,37 @@
           <a:p>
             <a:pPr lvl="0"/>
             <a:r>
-              <a:rPr lang="en-US" smtClean="0"/>
+              <a:rPr lang="en-US"/>
               <a:t>Click to edit Master text styles</a:t>
             </a:r>
           </a:p>
           <a:p>
             <a:pPr lvl="1"/>
             <a:r>
-              <a:rPr lang="en-US" smtClean="0"/>
+              <a:rPr lang="en-US"/>
               <a:t>Second level</a:t>
             </a:r>
           </a:p>
           <a:p>
             <a:pPr lvl="2"/>
             <a:r>
-              <a:rPr lang="en-US" smtClean="0"/>
+              <a:rPr lang="en-US"/>
               <a:t>Third level</a:t>
             </a:r>
           </a:p>
           <a:p>
             <a:pPr lvl="3"/>
             <a:r>
-              <a:rPr lang="en-US" smtClean="0"/>
+              <a:rPr lang="en-US"/>
               <a:t>Fourth level</a:t>
             </a:r>
           </a:p>
           <a:p>
             <a:pPr lvl="4"/>
             <a:r>
-              <a:rPr lang="en-US" smtClean="0"/>
+              <a:rPr lang="en-US"/>
               <a:t>Fifth level</a:t>
             </a:r>
-            <a:endParaRPr lang="en-US"/>
           </a:p>
         </p:txBody>
       </p:sp>
@@ -2240,7 +2238,7 @@
           <a:p>
             <a:pPr lvl="0"/>
             <a:r>
-              <a:rPr lang="en-US" smtClean="0"/>
+              <a:rPr lang="en-US"/>
               <a:t>Click to edit Master text styles</a:t>
             </a:r>
           </a:p>
@@ -2263,7 +2261,7 @@
           <a:p>
             <a:fld id="{5BCAD085-E8A6-8845-BD4E-CB4CCA059FC4}" type="datetimeFigureOut">
               <a:rPr lang="en-US" smtClean="0"/>
-              <a:t>1/27/13</a:t>
+              <a:t>9/21/2026</a:t>
             </a:fld>
             <a:endParaRPr lang="en-US"/>
           </a:p>
@@ -2366,10 +2364,9 @@
           </a:lstStyle>
           <a:p>
             <a:r>
-              <a:rPr lang="en-US" smtClean="0"/>
+              <a:rPr lang="en-US"/>
               <a:t>Click to edit Master title style</a:t>
             </a:r>
-            <a:endParaRPr lang="en-US"/>
           </a:p>
         </p:txBody>
       </p:sp>
@@ -2493,7 +2490,7 @@
           <a:p>
             <a:pPr lvl="0"/>
             <a:r>
-              <a:rPr lang="en-US" smtClean="0"/>
+              <a:rPr lang="en-US"/>
               <a:t>Click to edit Master text styles</a:t>
             </a:r>
           </a:p>
@@ -2516,7 +2513,7 @@
           <a:p>
             <a:fld id="{5BCAD085-E8A6-8845-BD4E-CB4CCA059FC4}" type="datetimeFigureOut">
               <a:rPr lang="en-US" smtClean="0"/>
-              <a:t>1/27/13</a:t>
+              <a:t>9/21/2026</a:t>
             </a:fld>
             <a:endParaRPr lang="en-US"/>
           </a:p>
@@ -2625,10 +2622,9 @@
           <a:lstStyle/>
           <a:p>
             <a:r>
-              <a:rPr lang="en-US" smtClean="0"/>
+              <a:rPr lang="en-US"/>
               <a:t>Click to edit Master title style</a:t>
             </a:r>
-            <a:endParaRPr lang="en-US"/>
           </a:p>
         </p:txBody>
       </p:sp>
@@ -2659,38 +2655,37 @@
           <a:p>
             <a:pPr lvl="0"/>
             <a:r>
-              <a:rPr lang="en-US" smtClean="0"/>
+              <a:rPr lang="en-US"/>
               <a:t>Click to edit Master text styles</a:t>
             </a:r>
           </a:p>
           <a:p>
             <a:pPr lvl="1"/>
             <a:r>
-              <a:rPr lang="en-US" smtClean="0"/>
+              <a:rPr lang="en-US"/>
               <a:t>Second level</a:t>
             </a:r>
           </a:p>
           <a:p>
             <a:pPr lvl="2"/>
             <a:r>
-              <a:rPr lang="en-US" smtClean="0"/>
+              <a:rPr lang="en-US"/>
               <a:t>Third level</a:t>
             </a:r>
           </a:p>
           <a:p>
             <a:pPr lvl="3"/>
             <a:r>
-              <a:rPr lang="en-US" smtClean="0"/>
+              <a:rPr lang="en-US"/>
               <a:t>Fourth level</a:t>
             </a:r>
           </a:p>
           <a:p>
             <a:pPr lvl="4"/>
             <a:r>
-              <a:rPr lang="en-US" smtClean="0"/>
+              <a:rPr lang="en-US"/>
               <a:t>Fifth level</a:t>
             </a:r>
-            <a:endParaRPr lang="en-US"/>
           </a:p>
         </p:txBody>
       </p:sp>
@@ -2729,7 +2724,7 @@
           <a:p>
             <a:fld id="{5BCAD085-E8A6-8845-BD4E-CB4CCA059FC4}" type="datetimeFigureOut">
               <a:rPr lang="en-US" smtClean="0"/>
-              <a:t>1/27/13</a:t>
+              <a:t>9/21/2026</a:t>
             </a:fld>
             <a:endParaRPr lang="en-US"/>
           </a:p>
@@ -3088,7 +3083,7 @@
 </file>
 
 <file path=ppt/slides/slide1.xml><?xml version="1.0" encoding="utf-8"?>
-<p:sld xmlns:a="http://schemas.openxmlformats.org/drawingml/2006/main" xmlns:p="http://schemas.openxmlformats.org/presentationml/2006/main" xmlns:r="http://schemas.openxmlformats.org/officeDocument/2006/relationships">
+<p:sld xmlns:a="http://schemas.openxmlformats.org/drawingml/2006/main" xmlns:r="http://schemas.openxmlformats.org/officeDocument/2006/relationships" xmlns:p="http://schemas.openxmlformats.org/presentationml/2006/main">
   <p:cSld>
     <p:spTree>
       <p:nvGrpSpPr>
@@ -3096,7 +3091,14 @@
         <p:cNvGrpSpPr/>
         <p:nvPr/>
       </p:nvGrpSpPr>
-      <p:grpSpPr/>
+      <p:grpSpPr>
+        <a:xfrm>
+          <a:off x="0" y="0"/>
+          <a:ext cx="0" cy="0"/>
+          <a:chOff x="0" y="0"/>
+          <a:chExt cx="0" cy="0"/>
+        </a:xfrm>
+      </p:grpSpPr>
       <p:sp>
         <p:nvSpPr>
           <p:cNvPr id="2" name="Rectangle 1"/>
@@ -3137,6 +3139,7 @@
           <a:lstStyle/>
           <a:p>
             <a:pPr algn="ctr"/>
+            <a:endParaRPr/>
           </a:p>
         </p:txBody>
       </p:sp>
@@ -3180,6 +3183,7 @@
           <a:lstStyle/>
           <a:p>
             <a:pPr algn="ctr"/>
+            <a:endParaRPr/>
           </a:p>
         </p:txBody>
       </p:sp>
@@ -3225,6 +3229,7 @@
           <a:lstStyle/>
           <a:p>
             <a:pPr algn="ctr"/>
+            <a:endParaRPr/>
           </a:p>
         </p:txBody>
       </p:sp>
@@ -3384,6 +3389,7 @@
           <a:lstStyle/>
           <a:p>
             <a:pPr algn="ctr"/>
+            <a:endParaRPr/>
           </a:p>
         </p:txBody>
       </p:sp>
@@ -3410,7 +3416,7 @@
           <a:lstStyle/>
           <a:p>
             <a:r>
-              <a:rPr b="1" sz="1050">
+              <a:rPr sz="1050" b="1">
                 <a:solidFill>
                   <a:srgbClr val="2B2024"/>
                 </a:solidFill>
@@ -3429,7 +3435,7 @@
 </a:t>
             </a:r>
             <a:r>
-              <a:rPr b="1" sz="1050">
+              <a:rPr sz="1050" b="1">
                 <a:solidFill>
                   <a:srgbClr val="2B2024"/>
                 </a:solidFill>
@@ -3448,7 +3454,7 @@
 </a:t>
             </a:r>
             <a:r>
-              <a:rPr b="1" sz="1050">
+              <a:rPr sz="1050" b="1">
                 <a:solidFill>
                   <a:srgbClr val="2B2024"/>
                 </a:solidFill>
@@ -3467,7 +3473,7 @@
 </a:t>
             </a:r>
             <a:r>
-              <a:rPr b="1" sz="1050">
+              <a:rPr sz="1050" b="1">
                 <a:solidFill>
                   <a:srgbClr val="2B2024"/>
                 </a:solidFill>
@@ -3529,6 +3535,7 @@
           <a:lstStyle/>
           <a:p>
             <a:pPr algn="ctr"/>
+            <a:endParaRPr/>
           </a:p>
         </p:txBody>
       </p:sp>
@@ -3565,7 +3572,7 @@
 </file>
 
 <file path=ppt/slides/slide10.xml><?xml version="1.0" encoding="utf-8"?>
-<p:sld xmlns:a="http://schemas.openxmlformats.org/drawingml/2006/main" xmlns:p="http://schemas.openxmlformats.org/presentationml/2006/main" xmlns:r="http://schemas.openxmlformats.org/officeDocument/2006/relationships">
+<p:sld xmlns:a="http://schemas.openxmlformats.org/drawingml/2006/main" xmlns:r="http://schemas.openxmlformats.org/officeDocument/2006/relationships" xmlns:p="http://schemas.openxmlformats.org/presentationml/2006/main">
   <p:cSld>
     <p:spTree>
       <p:nvGrpSpPr>
@@ -3573,7 +3580,14 @@
         <p:cNvGrpSpPr/>
         <p:nvPr/>
       </p:nvGrpSpPr>
-      <p:grpSpPr/>
+      <p:grpSpPr>
+        <a:xfrm>
+          <a:off x="0" y="0"/>
+          <a:ext cx="0" cy="0"/>
+          <a:chOff x="0" y="0"/>
+          <a:chExt cx="0" cy="0"/>
+        </a:xfrm>
+      </p:grpSpPr>
       <p:sp>
         <p:nvSpPr>
           <p:cNvPr id="2" name="Rectangle 1"/>
@@ -3614,6 +3628,7 @@
           <a:lstStyle/>
           <a:p>
             <a:pPr algn="ctr"/>
+            <a:endParaRPr/>
           </a:p>
         </p:txBody>
       </p:sp>
@@ -3626,7 +3641,7 @@
         <p:spPr>
           <a:xfrm>
             <a:off x="731520" y="365760"/>
-            <a:ext cx="7315200" cy="320040"/>
+            <a:ext cx="7315200" cy="246221"/>
           </a:xfrm>
           <a:prstGeom prst="rect">
             <a:avLst/>
@@ -3646,7 +3661,16 @@
                 </a:solidFill>
                 <a:latin typeface="Calibri"/>
               </a:rPr>
-              <a:t>✦ WHAT'S NEXT FOR LUMÉA ✦</a:t>
+              <a:t>WHAT'S </a:t>
+            </a:r>
+            <a:r>
+              <a:rPr sz="1000" b="1" dirty="0">
+                <a:solidFill>
+                  <a:srgbClr val="D96C8A"/>
+                </a:solidFill>
+                <a:latin typeface="Calibri"/>
+              </a:rPr>
+              <a:t>NEXT FOR LUMÉA </a:t>
             </a:r>
           </a:p>
         </p:txBody>
@@ -3725,6 +3749,7 @@
           <a:lstStyle/>
           <a:p>
             <a:pPr algn="ctr"/>
+            <a:endParaRPr/>
           </a:p>
         </p:txBody>
       </p:sp>
@@ -3770,6 +3795,7 @@
           <a:lstStyle/>
           <a:p>
             <a:pPr algn="ctr"/>
+            <a:endParaRPr/>
           </a:p>
         </p:txBody>
       </p:sp>
@@ -3796,7 +3822,7 @@
           <a:lstStyle/>
           <a:p>
             <a:r>
-              <a:rPr b="1" sz="1200">
+              <a:rPr sz="1200" b="1">
                 <a:solidFill>
                   <a:srgbClr val="A94B68"/>
                 </a:solidFill>
@@ -3865,6 +3891,7 @@
           <a:lstStyle/>
           <a:p>
             <a:pPr algn="ctr"/>
+            <a:endParaRPr/>
           </a:p>
         </p:txBody>
       </p:sp>
@@ -3891,7 +3918,7 @@
           <a:lstStyle/>
           <a:p>
             <a:r>
-              <a:rPr b="1" sz="1200">
+              <a:rPr sz="1200" b="1">
                 <a:solidFill>
                   <a:srgbClr val="A94B68"/>
                 </a:solidFill>
@@ -3960,6 +3987,7 @@
           <a:lstStyle/>
           <a:p>
             <a:pPr algn="ctr"/>
+            <a:endParaRPr/>
           </a:p>
         </p:txBody>
       </p:sp>
@@ -3986,7 +4014,7 @@
           <a:lstStyle/>
           <a:p>
             <a:r>
-              <a:rPr b="1" sz="1200">
+              <a:rPr sz="1200" b="1">
                 <a:solidFill>
                   <a:srgbClr val="A94B68"/>
                 </a:solidFill>
@@ -4055,6 +4083,7 @@
           <a:lstStyle/>
           <a:p>
             <a:pPr algn="ctr"/>
+            <a:endParaRPr/>
           </a:p>
         </p:txBody>
       </p:sp>
@@ -4081,7 +4110,7 @@
           <a:lstStyle/>
           <a:p>
             <a:r>
-              <a:rPr b="1" sz="1200">
+              <a:rPr sz="1200" b="1">
                 <a:solidFill>
                   <a:srgbClr val="A94B68"/>
                 </a:solidFill>
@@ -4117,7 +4146,7 @@
 </file>
 
 <file path=ppt/slides/slide2.xml><?xml version="1.0" encoding="utf-8"?>
-<p:sld xmlns:a="http://schemas.openxmlformats.org/drawingml/2006/main" xmlns:p="http://schemas.openxmlformats.org/presentationml/2006/main" xmlns:r="http://schemas.openxmlformats.org/officeDocument/2006/relationships">
+<p:sld xmlns:a="http://schemas.openxmlformats.org/drawingml/2006/main" xmlns:r="http://schemas.openxmlformats.org/officeDocument/2006/relationships" xmlns:p="http://schemas.openxmlformats.org/presentationml/2006/main">
   <p:cSld>
     <p:spTree>
       <p:nvGrpSpPr>
@@ -4125,7 +4154,14 @@
         <p:cNvGrpSpPr/>
         <p:nvPr/>
       </p:nvGrpSpPr>
-      <p:grpSpPr/>
+      <p:grpSpPr>
+        <a:xfrm>
+          <a:off x="0" y="0"/>
+          <a:ext cx="0" cy="0"/>
+          <a:chOff x="0" y="0"/>
+          <a:chExt cx="0" cy="0"/>
+        </a:xfrm>
+      </p:grpSpPr>
       <p:sp>
         <p:nvSpPr>
           <p:cNvPr id="2" name="Rectangle 1"/>
@@ -4166,6 +4202,7 @@
           <a:lstStyle/>
           <a:p>
             <a:pPr algn="ctr"/>
+            <a:endParaRPr/>
           </a:p>
         </p:txBody>
       </p:sp>
@@ -4178,7 +4215,7 @@
         <p:spPr>
           <a:xfrm>
             <a:off x="731520" y="365760"/>
-            <a:ext cx="7315200" cy="320040"/>
+            <a:ext cx="7315200" cy="246221"/>
           </a:xfrm>
           <a:prstGeom prst="rect">
             <a:avLst/>
@@ -4192,13 +4229,13 @@
           <a:lstStyle/>
           <a:p>
             <a:r>
-              <a:rPr sz="1000" b="1">
+              <a:rPr sz="1000" b="1" dirty="0">
                 <a:solidFill>
                   <a:srgbClr val="D96C8A"/>
                 </a:solidFill>
                 <a:latin typeface="Calibri"/>
               </a:rPr>
-              <a:t>✦ FLAGSHIP COSMETIC SHOWCASE ✦</a:t>
+              <a:t> FLAGSHIP COSMETIC SHOWCASE </a:t>
             </a:r>
           </a:p>
         </p:txBody>
@@ -4277,6 +4314,7 @@
           <a:lstStyle/>
           <a:p>
             <a:pPr algn="ctr"/>
+            <a:endParaRPr/>
           </a:p>
         </p:txBody>
       </p:sp>
@@ -4322,6 +4360,7 @@
           <a:lstStyle/>
           <a:p>
             <a:pPr algn="ctr"/>
+            <a:endParaRPr/>
           </a:p>
         </p:txBody>
       </p:sp>
@@ -4417,6 +4456,7 @@
           <a:lstStyle/>
           <a:p>
             <a:pPr algn="ctr"/>
+            <a:endParaRPr/>
           </a:p>
         </p:txBody>
       </p:sp>
@@ -4512,6 +4552,7 @@
           <a:lstStyle/>
           <a:p>
             <a:pPr algn="ctr"/>
+            <a:endParaRPr/>
           </a:p>
         </p:txBody>
       </p:sp>
@@ -4607,6 +4648,7 @@
           <a:lstStyle/>
           <a:p>
             <a:pPr algn="ctr"/>
+            <a:endParaRPr/>
           </a:p>
         </p:txBody>
       </p:sp>
@@ -4643,7 +4685,7 @@
 </file>
 
 <file path=ppt/slides/slide3.xml><?xml version="1.0" encoding="utf-8"?>
-<p:sld xmlns:a="http://schemas.openxmlformats.org/drawingml/2006/main" xmlns:p="http://schemas.openxmlformats.org/presentationml/2006/main" xmlns:r="http://schemas.openxmlformats.org/officeDocument/2006/relationships">
+<p:sld xmlns:a="http://schemas.openxmlformats.org/drawingml/2006/main" xmlns:r="http://schemas.openxmlformats.org/officeDocument/2006/relationships" xmlns:p="http://schemas.openxmlformats.org/presentationml/2006/main">
   <p:cSld>
     <p:spTree>
       <p:nvGrpSpPr>
@@ -4651,7 +4693,14 @@
         <p:cNvGrpSpPr/>
         <p:nvPr/>
       </p:nvGrpSpPr>
-      <p:grpSpPr/>
+      <p:grpSpPr>
+        <a:xfrm>
+          <a:off x="0" y="0"/>
+          <a:ext cx="0" cy="0"/>
+          <a:chOff x="0" y="0"/>
+          <a:chExt cx="0" cy="0"/>
+        </a:xfrm>
+      </p:grpSpPr>
       <p:sp>
         <p:nvSpPr>
           <p:cNvPr id="2" name="Rectangle 1"/>
@@ -4692,6 +4741,7 @@
           <a:lstStyle/>
           <a:p>
             <a:pPr algn="ctr"/>
+            <a:endParaRPr/>
           </a:p>
         </p:txBody>
       </p:sp>
@@ -4704,7 +4754,7 @@
         <p:spPr>
           <a:xfrm>
             <a:off x="731520" y="365760"/>
-            <a:ext cx="7315200" cy="320040"/>
+            <a:ext cx="7315200" cy="246221"/>
           </a:xfrm>
           <a:prstGeom prst="rect">
             <a:avLst/>
@@ -4718,13 +4768,13 @@
           <a:lstStyle/>
           <a:p>
             <a:r>
-              <a:rPr sz="1000" b="1">
+              <a:rPr sz="1000" b="1" dirty="0">
                 <a:solidFill>
                   <a:srgbClr val="D96C8A"/>
                 </a:solidFill>
                 <a:latin typeface="Calibri"/>
               </a:rPr>
-              <a:t>✦ SHADE SPECTRUM &amp; INCLUSIVITY ✦</a:t>
+              <a:t>✦SHADE SPECTRUM &amp; INCLUSIVITY </a:t>
             </a:r>
           </a:p>
         </p:txBody>
@@ -4803,6 +4853,7 @@
           <a:lstStyle/>
           <a:p>
             <a:pPr algn="ctr"/>
+            <a:endParaRPr/>
           </a:p>
         </p:txBody>
       </p:sp>
@@ -4848,6 +4899,7 @@
           <a:lstStyle/>
           <a:p>
             <a:pPr algn="ctr"/>
+            <a:endParaRPr/>
           </a:p>
         </p:txBody>
       </p:sp>
@@ -4893,6 +4945,7 @@
           <a:lstStyle/>
           <a:p>
             <a:pPr algn="ctr"/>
+            <a:endParaRPr/>
           </a:p>
         </p:txBody>
       </p:sp>
@@ -4919,7 +4972,7 @@
           <a:lstStyle/>
           <a:p>
             <a:r>
-              <a:rPr b="1" sz="1300">
+              <a:rPr sz="1300" b="1">
                 <a:solidFill>
                   <a:srgbClr val="2B2024"/>
                 </a:solidFill>
@@ -4997,6 +5050,7 @@
           <a:lstStyle/>
           <a:p>
             <a:pPr algn="ctr"/>
+            <a:endParaRPr/>
           </a:p>
         </p:txBody>
       </p:sp>
@@ -5042,6 +5096,7 @@
           <a:lstStyle/>
           <a:p>
             <a:pPr algn="ctr"/>
+            <a:endParaRPr/>
           </a:p>
         </p:txBody>
       </p:sp>
@@ -5068,7 +5123,7 @@
           <a:lstStyle/>
           <a:p>
             <a:r>
-              <a:rPr b="1" sz="1300">
+              <a:rPr sz="1300" b="1">
                 <a:solidFill>
                   <a:srgbClr val="2B2024"/>
                 </a:solidFill>
@@ -5146,6 +5201,7 @@
           <a:lstStyle/>
           <a:p>
             <a:pPr algn="ctr"/>
+            <a:endParaRPr/>
           </a:p>
         </p:txBody>
       </p:sp>
@@ -5191,6 +5247,7 @@
           <a:lstStyle/>
           <a:p>
             <a:pPr algn="ctr"/>
+            <a:endParaRPr/>
           </a:p>
         </p:txBody>
       </p:sp>
@@ -5217,7 +5274,7 @@
           <a:lstStyle/>
           <a:p>
             <a:r>
-              <a:rPr b="1" sz="1300">
+              <a:rPr sz="1300" b="1">
                 <a:solidFill>
                   <a:srgbClr val="2B2024"/>
                 </a:solidFill>
@@ -5295,6 +5352,7 @@
           <a:lstStyle/>
           <a:p>
             <a:pPr algn="ctr"/>
+            <a:endParaRPr/>
           </a:p>
         </p:txBody>
       </p:sp>
@@ -5340,6 +5398,7 @@
           <a:lstStyle/>
           <a:p>
             <a:pPr algn="ctr"/>
+            <a:endParaRPr/>
           </a:p>
         </p:txBody>
       </p:sp>
@@ -5366,7 +5425,7 @@
           <a:lstStyle/>
           <a:p>
             <a:r>
-              <a:rPr b="1" sz="1300">
+              <a:rPr sz="1300" b="1">
                 <a:solidFill>
                   <a:srgbClr val="2B2024"/>
                 </a:solidFill>
@@ -5444,6 +5503,7 @@
           <a:lstStyle/>
           <a:p>
             <a:pPr algn="ctr"/>
+            <a:endParaRPr/>
           </a:p>
         </p:txBody>
       </p:sp>
@@ -5489,6 +5549,7 @@
           <a:lstStyle/>
           <a:p>
             <a:pPr algn="ctr"/>
+            <a:endParaRPr/>
           </a:p>
         </p:txBody>
       </p:sp>
@@ -5515,7 +5576,7 @@
           <a:lstStyle/>
           <a:p>
             <a:r>
-              <a:rPr b="1" sz="1300">
+              <a:rPr sz="1300" b="1">
                 <a:solidFill>
                   <a:srgbClr val="2B2024"/>
                 </a:solidFill>
@@ -5593,6 +5654,7 @@
           <a:lstStyle/>
           <a:p>
             <a:pPr algn="ctr"/>
+            <a:endParaRPr/>
           </a:p>
         </p:txBody>
       </p:sp>
@@ -5638,6 +5700,7 @@
           <a:lstStyle/>
           <a:p>
             <a:pPr algn="ctr"/>
+            <a:endParaRPr/>
           </a:p>
         </p:txBody>
       </p:sp>
@@ -5664,7 +5727,7 @@
           <a:lstStyle/>
           <a:p>
             <a:r>
-              <a:rPr b="1" sz="1300">
+              <a:rPr sz="1300" b="1">
                 <a:solidFill>
                   <a:srgbClr val="2B2024"/>
                 </a:solidFill>
@@ -5709,7 +5772,7 @@
 </file>
 
 <file path=ppt/slides/slide4.xml><?xml version="1.0" encoding="utf-8"?>
-<p:sld xmlns:a="http://schemas.openxmlformats.org/drawingml/2006/main" xmlns:p="http://schemas.openxmlformats.org/presentationml/2006/main" xmlns:r="http://schemas.openxmlformats.org/officeDocument/2006/relationships">
+<p:sld xmlns:a="http://schemas.openxmlformats.org/drawingml/2006/main" xmlns:r="http://schemas.openxmlformats.org/officeDocument/2006/relationships" xmlns:p="http://schemas.openxmlformats.org/presentationml/2006/main">
   <p:cSld>
     <p:spTree>
       <p:nvGrpSpPr>
@@ -5717,7 +5780,14 @@
         <p:cNvGrpSpPr/>
         <p:nvPr/>
       </p:nvGrpSpPr>
-      <p:grpSpPr/>
+      <p:grpSpPr>
+        <a:xfrm>
+          <a:off x="0" y="0"/>
+          <a:ext cx="0" cy="0"/>
+          <a:chOff x="0" y="0"/>
+          <a:chExt cx="0" cy="0"/>
+        </a:xfrm>
+      </p:grpSpPr>
       <p:sp>
         <p:nvSpPr>
           <p:cNvPr id="2" name="Rectangle 1"/>
@@ -5758,6 +5828,7 @@
           <a:lstStyle/>
           <a:p>
             <a:pPr algn="ctr"/>
+            <a:endParaRPr/>
           </a:p>
         </p:txBody>
       </p:sp>
@@ -5770,7 +5841,7 @@
         <p:spPr>
           <a:xfrm>
             <a:off x="731520" y="365760"/>
-            <a:ext cx="7315200" cy="320040"/>
+            <a:ext cx="7315200" cy="246221"/>
           </a:xfrm>
           <a:prstGeom prst="rect">
             <a:avLst/>
@@ -5784,13 +5855,13 @@
           <a:lstStyle/>
           <a:p>
             <a:r>
-              <a:rPr sz="1000" b="1">
+              <a:rPr sz="1000" b="1" dirty="0">
                 <a:solidFill>
                   <a:srgbClr val="D96C8A"/>
                 </a:solidFill>
                 <a:latin typeface="Calibri"/>
               </a:rPr>
-              <a:t>✦ PROBLEM &amp; SOLUTION ANALYSIS ✦</a:t>
+              <a:t>✦PROBLEM &amp; SOLUTION ANALYSIS </a:t>
             </a:r>
           </a:p>
         </p:txBody>
@@ -5869,6 +5940,7 @@
           <a:lstStyle/>
           <a:p>
             <a:pPr algn="ctr"/>
+            <a:endParaRPr/>
           </a:p>
         </p:txBody>
       </p:sp>
@@ -5914,6 +5986,7 @@
           <a:lstStyle/>
           <a:p>
             <a:pPr algn="ctr"/>
+            <a:endParaRPr/>
           </a:p>
         </p:txBody>
       </p:sp>
@@ -5940,7 +6013,7 @@
           <a:lstStyle/>
           <a:p>
             <a:r>
-              <a:rPr b="1" sz="1400">
+              <a:rPr sz="1400" b="1">
                 <a:solidFill>
                   <a:srgbClr val="BE283C"/>
                 </a:solidFill>
@@ -6012,6 +6085,7 @@
           <a:lstStyle/>
           <a:p>
             <a:pPr algn="ctr"/>
+            <a:endParaRPr/>
           </a:p>
         </p:txBody>
       </p:sp>
@@ -6038,7 +6112,7 @@
           <a:lstStyle/>
           <a:p>
             <a:r>
-              <a:rPr b="1" sz="1400">
+              <a:rPr sz="1400" b="1">
                 <a:solidFill>
                   <a:srgbClr val="A94B68"/>
                 </a:solidFill>
@@ -6077,7 +6151,7 @@
 </file>
 
 <file path=ppt/slides/slide5.xml><?xml version="1.0" encoding="utf-8"?>
-<p:sld xmlns:a="http://schemas.openxmlformats.org/drawingml/2006/main" xmlns:p="http://schemas.openxmlformats.org/presentationml/2006/main" xmlns:r="http://schemas.openxmlformats.org/officeDocument/2006/relationships">
+<p:sld xmlns:a="http://schemas.openxmlformats.org/drawingml/2006/main" xmlns:r="http://schemas.openxmlformats.org/officeDocument/2006/relationships" xmlns:p="http://schemas.openxmlformats.org/presentationml/2006/main">
   <p:cSld>
     <p:spTree>
       <p:nvGrpSpPr>
@@ -6085,7 +6159,14 @@
         <p:cNvGrpSpPr/>
         <p:nvPr/>
       </p:nvGrpSpPr>
-      <p:grpSpPr/>
+      <p:grpSpPr>
+        <a:xfrm>
+          <a:off x="0" y="0"/>
+          <a:ext cx="0" cy="0"/>
+          <a:chOff x="0" y="0"/>
+          <a:chExt cx="0" cy="0"/>
+        </a:xfrm>
+      </p:grpSpPr>
       <p:sp>
         <p:nvSpPr>
           <p:cNvPr id="2" name="Rectangle 1"/>
@@ -6126,6 +6207,7 @@
           <a:lstStyle/>
           <a:p>
             <a:pPr algn="ctr"/>
+            <a:endParaRPr/>
           </a:p>
         </p:txBody>
       </p:sp>
@@ -6138,7 +6220,7 @@
         <p:spPr>
           <a:xfrm>
             <a:off x="731520" y="365760"/>
-            <a:ext cx="7315200" cy="320040"/>
+            <a:ext cx="7315200" cy="246221"/>
           </a:xfrm>
           <a:prstGeom prst="rect">
             <a:avLst/>
@@ -6152,13 +6234,13 @@
           <a:lstStyle/>
           <a:p>
             <a:r>
-              <a:rPr sz="1000" b="1">
+              <a:rPr sz="1000" b="1" dirty="0">
                 <a:solidFill>
                   <a:srgbClr val="D96C8A"/>
                 </a:solidFill>
                 <a:latin typeface="Calibri"/>
               </a:rPr>
-              <a:t>✦ ENGINEERING FOUNDATION ✦</a:t>
+              <a:t> ENGINEERING FOUNDATION </a:t>
             </a:r>
           </a:p>
         </p:txBody>
@@ -6237,6 +6319,7 @@
           <a:lstStyle/>
           <a:p>
             <a:pPr algn="ctr"/>
+            <a:endParaRPr/>
           </a:p>
         </p:txBody>
       </p:sp>
@@ -6282,6 +6365,7 @@
           <a:lstStyle/>
           <a:p>
             <a:pPr algn="ctr"/>
+            <a:endParaRPr/>
           </a:p>
         </p:txBody>
       </p:sp>
@@ -6308,7 +6392,7 @@
           <a:lstStyle/>
           <a:p>
             <a:r>
-              <a:rPr b="1" sz="1200">
+              <a:rPr sz="1200" b="1">
                 <a:solidFill>
                   <a:srgbClr val="A94B68"/>
                 </a:solidFill>
@@ -6372,6 +6456,7 @@
           <a:lstStyle/>
           <a:p>
             <a:pPr algn="ctr"/>
+            <a:endParaRPr/>
           </a:p>
         </p:txBody>
       </p:sp>
@@ -6398,7 +6483,7 @@
           <a:lstStyle/>
           <a:p>
             <a:r>
-              <a:rPr b="1" sz="1200">
+              <a:rPr sz="1200" b="1">
                 <a:solidFill>
                   <a:srgbClr val="A94B68"/>
                 </a:solidFill>
@@ -6462,6 +6547,7 @@
           <a:lstStyle/>
           <a:p>
             <a:pPr algn="ctr"/>
+            <a:endParaRPr/>
           </a:p>
         </p:txBody>
       </p:sp>
@@ -6488,7 +6574,7 @@
           <a:lstStyle/>
           <a:p>
             <a:r>
-              <a:rPr b="1" sz="1200">
+              <a:rPr sz="1200" b="1">
                 <a:solidFill>
                   <a:srgbClr val="A94B68"/>
                 </a:solidFill>
@@ -6552,6 +6638,7 @@
           <a:lstStyle/>
           <a:p>
             <a:pPr algn="ctr"/>
+            <a:endParaRPr/>
           </a:p>
         </p:txBody>
       </p:sp>
@@ -6578,7 +6665,7 @@
           <a:lstStyle/>
           <a:p>
             <a:r>
-              <a:rPr b="1" sz="1200">
+              <a:rPr sz="1200" b="1">
                 <a:solidFill>
                   <a:srgbClr val="A94B68"/>
                 </a:solidFill>
@@ -6642,6 +6729,7 @@
           <a:lstStyle/>
           <a:p>
             <a:pPr algn="ctr"/>
+            <a:endParaRPr/>
           </a:p>
         </p:txBody>
       </p:sp>
@@ -6678,7 +6766,7 @@
 </file>
 
 <file path=ppt/slides/slide6.xml><?xml version="1.0" encoding="utf-8"?>
-<p:sld xmlns:a="http://schemas.openxmlformats.org/drawingml/2006/main" xmlns:p="http://schemas.openxmlformats.org/presentationml/2006/main" xmlns:r="http://schemas.openxmlformats.org/officeDocument/2006/relationships">
+<p:sld xmlns:a="http://schemas.openxmlformats.org/drawingml/2006/main" xmlns:r="http://schemas.openxmlformats.org/officeDocument/2006/relationships" xmlns:p="http://schemas.openxmlformats.org/presentationml/2006/main">
   <p:cSld>
     <p:spTree>
       <p:nvGrpSpPr>
@@ -6686,7 +6774,14 @@
         <p:cNvGrpSpPr/>
         <p:nvPr/>
       </p:nvGrpSpPr>
-      <p:grpSpPr/>
+      <p:grpSpPr>
+        <a:xfrm>
+          <a:off x="0" y="0"/>
+          <a:ext cx="0" cy="0"/>
+          <a:chOff x="0" y="0"/>
+          <a:chExt cx="0" cy="0"/>
+        </a:xfrm>
+      </p:grpSpPr>
       <p:sp>
         <p:nvSpPr>
           <p:cNvPr id="2" name="Rectangle 1"/>
@@ -6727,6 +6822,7 @@
           <a:lstStyle/>
           <a:p>
             <a:pPr algn="ctr"/>
+            <a:endParaRPr/>
           </a:p>
         </p:txBody>
       </p:sp>
@@ -6739,7 +6835,7 @@
         <p:spPr>
           <a:xfrm>
             <a:off x="731520" y="365760"/>
-            <a:ext cx="7315200" cy="320040"/>
+            <a:ext cx="7315200" cy="246221"/>
           </a:xfrm>
           <a:prstGeom prst="rect">
             <a:avLst/>
@@ -6753,13 +6849,13 @@
           <a:lstStyle/>
           <a:p>
             <a:r>
-              <a:rPr sz="1000" b="1">
+              <a:rPr sz="1000" b="1" dirty="0">
                 <a:solidFill>
                   <a:srgbClr val="D96C8A"/>
                 </a:solidFill>
                 <a:latin typeface="Calibri"/>
               </a:rPr>
-              <a:t>✦ FRONTEND INTERACTIVITY &amp; DESIGN ✦</a:t>
+              <a:t>✦FRONTEND INTERACTIVITY &amp; DESIGN </a:t>
             </a:r>
           </a:p>
         </p:txBody>
@@ -6838,6 +6934,7 @@
           <a:lstStyle/>
           <a:p>
             <a:pPr algn="ctr"/>
+            <a:endParaRPr/>
           </a:p>
         </p:txBody>
       </p:sp>
@@ -6883,6 +6980,7 @@
           <a:lstStyle/>
           <a:p>
             <a:pPr algn="ctr"/>
+            <a:endParaRPr/>
           </a:p>
         </p:txBody>
       </p:sp>
@@ -6909,7 +7007,7 @@
           <a:lstStyle/>
           <a:p>
             <a:r>
-              <a:rPr b="1" sz="1400">
+              <a:rPr sz="1400" b="1">
                 <a:solidFill>
                   <a:srgbClr val="2B2024"/>
                 </a:solidFill>
@@ -6983,6 +7081,7 @@
           <a:lstStyle/>
           <a:p>
             <a:pPr algn="ctr"/>
+            <a:endParaRPr/>
           </a:p>
         </p:txBody>
       </p:sp>
@@ -7019,7 +7118,7 @@
 </file>
 
 <file path=ppt/slides/slide7.xml><?xml version="1.0" encoding="utf-8"?>
-<p:sld xmlns:a="http://schemas.openxmlformats.org/drawingml/2006/main" xmlns:p="http://schemas.openxmlformats.org/presentationml/2006/main" xmlns:r="http://schemas.openxmlformats.org/officeDocument/2006/relationships">
+<p:sld xmlns:a="http://schemas.openxmlformats.org/drawingml/2006/main" xmlns:r="http://schemas.openxmlformats.org/officeDocument/2006/relationships" xmlns:p="http://schemas.openxmlformats.org/presentationml/2006/main">
   <p:cSld>
     <p:spTree>
       <p:nvGrpSpPr>
@@ -7027,7 +7126,14 @@
         <p:cNvGrpSpPr/>
         <p:nvPr/>
       </p:nvGrpSpPr>
-      <p:grpSpPr/>
+      <p:grpSpPr>
+        <a:xfrm>
+          <a:off x="0" y="0"/>
+          <a:ext cx="0" cy="0"/>
+          <a:chOff x="0" y="0"/>
+          <a:chExt cx="0" cy="0"/>
+        </a:xfrm>
+      </p:grpSpPr>
       <p:sp>
         <p:nvSpPr>
           <p:cNvPr id="2" name="Rectangle 1"/>
@@ -7068,6 +7174,7 @@
           <a:lstStyle/>
           <a:p>
             <a:pPr algn="ctr"/>
+            <a:endParaRPr/>
           </a:p>
         </p:txBody>
       </p:sp>
@@ -7080,7 +7187,7 @@
         <p:spPr>
           <a:xfrm>
             <a:off x="731520" y="365760"/>
-            <a:ext cx="7315200" cy="320040"/>
+            <a:ext cx="7315200" cy="246221"/>
           </a:xfrm>
           <a:prstGeom prst="rect">
             <a:avLst/>
@@ -7094,13 +7201,13 @@
           <a:lstStyle/>
           <a:p>
             <a:r>
-              <a:rPr sz="1000" b="1">
+              <a:rPr sz="1000" b="1" dirty="0">
                 <a:solidFill>
                   <a:srgbClr val="D96C8A"/>
                 </a:solidFill>
                 <a:latin typeface="Calibri"/>
               </a:rPr>
-              <a:t>✦ TRANSACTIONAL INTEGRITY ✦</a:t>
+              <a:t>✦TRANSACTIONAL INTEGRITY </a:t>
             </a:r>
           </a:p>
         </p:txBody>
@@ -7179,6 +7286,7 @@
           <a:lstStyle/>
           <a:p>
             <a:pPr algn="ctr"/>
+            <a:endParaRPr/>
           </a:p>
         </p:txBody>
       </p:sp>
@@ -7224,6 +7332,7 @@
           <a:lstStyle/>
           <a:p>
             <a:pPr algn="ctr"/>
+            <a:endParaRPr/>
           </a:p>
         </p:txBody>
       </p:sp>
@@ -7250,7 +7359,7 @@
           <a:lstStyle/>
           <a:p>
             <a:r>
-              <a:rPr b="1" sz="1200">
+              <a:rPr sz="1200" b="1">
                 <a:solidFill>
                   <a:srgbClr val="A94B68"/>
                 </a:solidFill>
@@ -7321,6 +7430,7 @@
           <a:lstStyle/>
           <a:p>
             <a:pPr algn="ctr"/>
+            <a:endParaRPr/>
           </a:p>
         </p:txBody>
       </p:sp>
@@ -7347,7 +7457,7 @@
           <a:lstStyle/>
           <a:p>
             <a:r>
-              <a:rPr b="1" sz="1200">
+              <a:rPr sz="1200" b="1">
                 <a:solidFill>
                   <a:srgbClr val="A94B68"/>
                 </a:solidFill>
@@ -7418,6 +7528,7 @@
           <a:lstStyle/>
           <a:p>
             <a:pPr algn="ctr"/>
+            <a:endParaRPr/>
           </a:p>
         </p:txBody>
       </p:sp>
@@ -7454,7 +7565,7 @@
 </file>
 
 <file path=ppt/slides/slide8.xml><?xml version="1.0" encoding="utf-8"?>
-<p:sld xmlns:a="http://schemas.openxmlformats.org/drawingml/2006/main" xmlns:p="http://schemas.openxmlformats.org/presentationml/2006/main" xmlns:r="http://schemas.openxmlformats.org/officeDocument/2006/relationships">
+<p:sld xmlns:a="http://schemas.openxmlformats.org/drawingml/2006/main" xmlns:r="http://schemas.openxmlformats.org/officeDocument/2006/relationships" xmlns:p="http://schemas.openxmlformats.org/presentationml/2006/main">
   <p:cSld>
     <p:spTree>
       <p:nvGrpSpPr>
@@ -7462,7 +7573,14 @@
         <p:cNvGrpSpPr/>
         <p:nvPr/>
       </p:nvGrpSpPr>
-      <p:grpSpPr/>
+      <p:grpSpPr>
+        <a:xfrm>
+          <a:off x="0" y="0"/>
+          <a:ext cx="0" cy="0"/>
+          <a:chOff x="0" y="0"/>
+          <a:chExt cx="0" cy="0"/>
+        </a:xfrm>
+      </p:grpSpPr>
       <p:sp>
         <p:nvSpPr>
           <p:cNvPr id="2" name="Rectangle 1"/>
@@ -7503,6 +7621,7 @@
           <a:lstStyle/>
           <a:p>
             <a:pPr algn="ctr"/>
+            <a:endParaRPr/>
           </a:p>
         </p:txBody>
       </p:sp>
@@ -7515,7 +7634,7 @@
         <p:spPr>
           <a:xfrm>
             <a:off x="731520" y="365760"/>
-            <a:ext cx="7315200" cy="320040"/>
+            <a:ext cx="7315200" cy="246221"/>
           </a:xfrm>
           <a:prstGeom prst="rect">
             <a:avLst/>
@@ -7529,13 +7648,13 @@
           <a:lstStyle/>
           <a:p>
             <a:r>
-              <a:rPr sz="1000" b="1">
+              <a:rPr sz="1000" b="1" dirty="0">
                 <a:solidFill>
                   <a:srgbClr val="D96C8A"/>
                 </a:solidFill>
                 <a:latin typeface="Calibri"/>
               </a:rPr>
-              <a:t>✦ ROLE-BASED SECURITY ✦</a:t>
+              <a:t>ROLE-BASED SECURITY </a:t>
             </a:r>
           </a:p>
         </p:txBody>
@@ -7614,6 +7733,7 @@
           <a:lstStyle/>
           <a:p>
             <a:pPr algn="ctr"/>
+            <a:endParaRPr/>
           </a:p>
         </p:txBody>
       </p:sp>
@@ -7659,6 +7779,7 @@
           <a:lstStyle/>
           <a:p>
             <a:pPr algn="ctr"/>
+            <a:endParaRPr/>
           </a:p>
         </p:txBody>
       </p:sp>
@@ -7685,7 +7806,7 @@
           <a:lstStyle/>
           <a:p>
             <a:r>
-              <a:rPr b="1" sz="1300">
+              <a:rPr sz="1300" b="1">
                 <a:solidFill>
                   <a:srgbClr val="2B2024"/>
                 </a:solidFill>
@@ -7764,6 +7885,7 @@
           <a:lstStyle/>
           <a:p>
             <a:pPr algn="ctr"/>
+            <a:endParaRPr/>
           </a:p>
         </p:txBody>
       </p:sp>
@@ -7800,7 +7922,7 @@
 </file>
 
 <file path=ppt/slides/slide9.xml><?xml version="1.0" encoding="utf-8"?>
-<p:sld xmlns:a="http://schemas.openxmlformats.org/drawingml/2006/main" xmlns:p="http://schemas.openxmlformats.org/presentationml/2006/main" xmlns:r="http://schemas.openxmlformats.org/officeDocument/2006/relationships">
+<p:sld xmlns:a="http://schemas.openxmlformats.org/drawingml/2006/main" xmlns:r="http://schemas.openxmlformats.org/officeDocument/2006/relationships" xmlns:p="http://schemas.openxmlformats.org/presentationml/2006/main">
   <p:cSld>
     <p:spTree>
       <p:nvGrpSpPr>
@@ -7808,7 +7930,14 @@
         <p:cNvGrpSpPr/>
         <p:nvPr/>
       </p:nvGrpSpPr>
-      <p:grpSpPr/>
+      <p:grpSpPr>
+        <a:xfrm>
+          <a:off x="0" y="0"/>
+          <a:ext cx="0" cy="0"/>
+          <a:chOff x="0" y="0"/>
+          <a:chExt cx="0" cy="0"/>
+        </a:xfrm>
+      </p:grpSpPr>
       <p:sp>
         <p:nvSpPr>
           <p:cNvPr id="2" name="Rectangle 1"/>
@@ -7849,6 +7978,7 @@
           <a:lstStyle/>
           <a:p>
             <a:pPr algn="ctr"/>
+            <a:endParaRPr/>
           </a:p>
         </p:txBody>
       </p:sp>
@@ -7861,7 +7991,7 @@
         <p:spPr>
           <a:xfrm>
             <a:off x="731520" y="365760"/>
-            <a:ext cx="7315200" cy="320040"/>
+            <a:ext cx="7315200" cy="246221"/>
           </a:xfrm>
           <a:prstGeom prst="rect">
             <a:avLst/>
@@ -7875,13 +8005,13 @@
           <a:lstStyle/>
           <a:p>
             <a:r>
-              <a:rPr sz="1000" b="1">
+              <a:rPr sz="1000" b="1" dirty="0">
                 <a:solidFill>
                   <a:srgbClr val="D96C8A"/>
                 </a:solidFill>
                 <a:latin typeface="Calibri"/>
               </a:rPr>
-              <a:t>✦ STABILITY &amp; RESILIENCE ✦</a:t>
+              <a:t>STABILITY &amp; RESILIENCE </a:t>
             </a:r>
           </a:p>
         </p:txBody>
@@ -7960,6 +8090,7 @@
           <a:lstStyle/>
           <a:p>
             <a:pPr algn="ctr"/>
+            <a:endParaRPr/>
           </a:p>
         </p:txBody>
       </p:sp>
@@ -8005,6 +8136,7 @@
           <a:lstStyle/>
           <a:p>
             <a:pPr algn="ctr"/>
+            <a:endParaRPr/>
           </a:p>
         </p:txBody>
       </p:sp>
@@ -8031,7 +8163,7 @@
           <a:lstStyle/>
           <a:p>
             <a:r>
-              <a:rPr b="1" sz="1300">
+              <a:rPr sz="1300" b="1">
                 <a:solidFill>
                   <a:srgbClr val="A94B68"/>
                 </a:solidFill>
@@ -8100,6 +8232,7 @@
           <a:lstStyle/>
           <a:p>
             <a:pPr algn="ctr"/>
+            <a:endParaRPr/>
           </a:p>
         </p:txBody>
       </p:sp>
@@ -8126,7 +8259,7 @@
           <a:lstStyle/>
           <a:p>
             <a:r>
-              <a:rPr b="1" sz="1300">
+              <a:rPr sz="1300" b="1">
                 <a:solidFill>
                   <a:srgbClr val="A94B68"/>
                 </a:solidFill>
@@ -8195,6 +8328,7 @@
           <a:lstStyle/>
           <a:p>
             <a:pPr algn="ctr"/>
+            <a:endParaRPr/>
           </a:p>
         </p:txBody>
       </p:sp>
@@ -8221,7 +8355,7 @@
           <a:lstStyle/>
           <a:p>
             <a:r>
-              <a:rPr b="1" sz="1300">
+              <a:rPr sz="1300" b="1">
                 <a:solidFill>
                   <a:srgbClr val="A94B68"/>
                 </a:solidFill>
@@ -8290,6 +8424,7 @@
           <a:lstStyle/>
           <a:p>
             <a:pPr algn="ctr"/>
+            <a:endParaRPr/>
           </a:p>
         </p:txBody>
       </p:sp>

</xml_diff>